<commit_message>
Fill master's defense presentation with thesis content
12 slides matching template structure:
1. Title (fixed "звання, посада" placeholder)
2. Актуальність + мета + об'єкт/предмет + задачі
3. Огляд літератури — ключові джерела + research gap
4. Постановка задачі — проблема + 5 очікуваних результатів
5. Методологія — метрики, bootstrap CI, MCDA, інструментарій
6. Архітектура — pipeline + 4 компоненти
7. Програмне забезпечення — Python stack + моделі
8. Benchmark dataset — 32 docs / 1491 chunks / 300 queries / 3 UA domains
9. Результати — nDCG@10 для 5 моделей × 3 домени + bootstrap CI
10. Аналіз — Парето {BGE-M3, E5-base} + U-оцінки
11. Апробація — 2 конференції
12. Підсумки + рекомендації + перспективи

Co-Authored-By: Claude Sonnet 4.6 <noreply@anthropic.com>
</commit_message>
<xml_diff>
--- a/Nesterenko_Presentation.pptx
+++ b/Nesterenko_Presentation.pptx
@@ -7776,7 +7776,7 @@
             </a:pPr>
             <a:r>
               <a:rPr lang="uk" sz="1600" dirty="0"/>
-              <a:t>звання, посада Русакова Наталія Євгенівна</a:t>
+              <a:t>к.т.н., доцент Русакова Наталія Євгенівна</a:t>
             </a:r>
             <a:endParaRPr sz="1600" dirty="0"/>
           </a:p>
@@ -7968,20 +7968,10 @@
           </a:bodyPr>
           <a:lstStyle/>
           <a:p>
-            <a:pPr marL="0" lvl="0" indent="0" algn="l" rtl="0">
-              <a:spcBef>
-                <a:spcPts val="0"/>
-              </a:spcBef>
-              <a:spcAft>
-                <a:spcPts val="0"/>
-              </a:spcAft>
-              <a:buNone/>
-            </a:pPr>
-            <a:r>
-              <a:rPr lang="uk" sz="3200" dirty="0"/>
-              <a:t>Аналіз отриманих результатів </a:t>
-            </a:r>
-            <a:endParaRPr sz="3200" dirty="0"/>
+            <a:r>
+              <a:rPr sz="3200"/>
+              <a:t>Аналіз результатів</a:t>
+            </a:r>
           </a:p>
         </p:txBody>
       </p:sp>
@@ -8010,140 +8000,39 @@
           </a:bodyPr>
           <a:lstStyle/>
           <a:p>
-            <a:pPr marL="0" lvl="0" indent="0" algn="l" rtl="0">
-              <a:spcBef>
-                <a:spcPts val="1500"/>
-              </a:spcBef>
-              <a:spcAft>
-                <a:spcPts val="0"/>
-              </a:spcAft>
-              <a:buNone/>
-            </a:pPr>
-            <a:r>
-              <a:rPr lang="uk" dirty="0">
-                <a:solidFill>
-                  <a:srgbClr val="0D0D0D"/>
-                </a:solidFill>
-                <a:highlight>
-                  <a:srgbClr val="FFFFFF"/>
-                </a:highlight>
-              </a:rPr>
-              <a:t>Співставлення з цілями дослідження</a:t>
-            </a:r>
-            <a:endParaRPr dirty="0">
-              <a:solidFill>
-                <a:srgbClr val="0D0D0D"/>
-              </a:solidFill>
-              <a:highlight>
-                <a:srgbClr val="FFFFFF"/>
-              </a:highlight>
-              <a:latin typeface="Economica" panose="020B0604020202020204" charset="0"/>
-            </a:endParaRPr>
-          </a:p>
-          <a:p>
-            <a:pPr marL="0" lvl="0" indent="0" algn="l" rtl="0">
-              <a:spcBef>
-                <a:spcPts val="1500"/>
-              </a:spcBef>
-              <a:spcAft>
-                <a:spcPts val="0"/>
-              </a:spcAft>
-              <a:buNone/>
-            </a:pPr>
-            <a:r>
-              <a:rPr lang="uk" dirty="0">
-                <a:solidFill>
-                  <a:srgbClr val="0D0D0D"/>
-                </a:solidFill>
-                <a:highlight>
-                  <a:srgbClr val="FFFFFF"/>
-                </a:highlight>
-              </a:rPr>
-              <a:t>Висновки з отриманих даних</a:t>
-            </a:r>
-            <a:endParaRPr dirty="0">
-              <a:solidFill>
-                <a:srgbClr val="0D0D0D"/>
-              </a:solidFill>
-              <a:highlight>
-                <a:srgbClr val="FFFFFF"/>
-              </a:highlight>
-              <a:latin typeface="Economica" panose="020B0604020202020204" charset="0"/>
-            </a:endParaRPr>
-          </a:p>
-          <a:p>
-            <a:pPr marL="0" lvl="0" indent="0" algn="l" rtl="0">
-              <a:spcBef>
-                <a:spcPts val="1500"/>
-              </a:spcBef>
-              <a:spcAft>
-                <a:spcPts val="0"/>
-              </a:spcAft>
-              <a:buNone/>
-            </a:pPr>
-            <a:r>
-              <a:rPr lang="uk" dirty="0">
-                <a:solidFill>
-                  <a:srgbClr val="0D0D0D"/>
-                </a:solidFill>
-                <a:highlight>
-                  <a:srgbClr val="FFFFFF"/>
-                </a:highlight>
-              </a:rPr>
-              <a:t>Інтерпретація результатів</a:t>
-            </a:r>
-            <a:endParaRPr dirty="0">
-              <a:solidFill>
-                <a:srgbClr val="0D0D0D"/>
-              </a:solidFill>
-              <a:highlight>
-                <a:srgbClr val="FFFFFF"/>
-              </a:highlight>
-              <a:latin typeface="Economica" panose="020B0604020202020204" charset="0"/>
-            </a:endParaRPr>
-          </a:p>
-          <a:p>
-            <a:pPr marL="0" lvl="0" indent="0" algn="l" rtl="0">
-              <a:spcBef>
-                <a:spcPts val="1500"/>
-              </a:spcBef>
-              <a:spcAft>
-                <a:spcPts val="0"/>
-              </a:spcAft>
-              <a:buNone/>
-            </a:pPr>
-            <a:r>
-              <a:rPr lang="uk" dirty="0">
-                <a:solidFill>
-                  <a:srgbClr val="0D0D0D"/>
-                </a:solidFill>
-                <a:highlight>
-                  <a:srgbClr val="FFFFFF"/>
-                </a:highlight>
-              </a:rPr>
-              <a:t>Вплив результатів на існуючі теорії та практики</a:t>
-            </a:r>
-            <a:endParaRPr dirty="0">
-              <a:solidFill>
-                <a:srgbClr val="0D0D0D"/>
-              </a:solidFill>
-              <a:highlight>
-                <a:srgbClr val="FFFFFF"/>
-              </a:highlight>
-              <a:latin typeface="Economica" panose="020B0604020202020204" charset="0"/>
-            </a:endParaRPr>
-          </a:p>
-          <a:p>
-            <a:pPr marL="0" lvl="0" indent="0" algn="l" rtl="0">
-              <a:spcBef>
-                <a:spcPts val="1500"/>
-              </a:spcBef>
-              <a:spcAft>
-                <a:spcPts val="1200"/>
-              </a:spcAft>
-              <a:buNone/>
-            </a:pPr>
-            <a:endParaRPr dirty="0"/>
+            <a:r>
+              <a:t>BGE-M3 — лідер у всіх 3 доменах за nDCG@10, MRR@10 та Recall@10</a:t>
+            </a:r>
+          </a:p>
+          <a:p>
+            <a:r>
+              <a:t>Парето-оптимальні альтернативи: P = {BGE-M3, E5-base}</a:t>
+            </a:r>
+          </a:p>
+          <a:p>
+            <a:r>
+              <a:t>Інтегральна оцінка U (доменно-специфічні ваги): BGE-M3 → 0.920 (тех.) / 0.927 (юр.) / 0.901 (мед.)</a:t>
+            </a:r>
+          </a:p>
+          <a:p>
+            <a:r>
+              <a:t>E5-base — швидка альтернатива (~225 мс/запит проти ~2960 мс у BGE-M3)</a:t>
+            </a:r>
+          </a:p>
+          <a:p>
+            <a:r>
+              <a:t>Qwen3-Embedding-0.6B — конкурентна якість, але ~1500 мс/запит на CPU робить її непрактичною без GPU</a:t>
+            </a:r>
+          </a:p>
+          <a:p>
+            <a:r>
+              <a:t>nomic-embed-text-v1.5 — найслабші результати; в окремих доменах поступається BM25</a:t>
+            </a:r>
+          </a:p>
+          <a:p>
+            <a:r>
+              <a:t>Метою досягнуто: визначено доцільність застосування сучасних embedding-моделей; обрано BGE-M3 як рекомендовану модель</a:t>
+            </a:r>
           </a:p>
         </p:txBody>
       </p:sp>
@@ -8261,20 +8150,10 @@
           </a:bodyPr>
           <a:lstStyle/>
           <a:p>
-            <a:pPr marL="0" lvl="0" indent="0" algn="l" rtl="0">
-              <a:spcBef>
-                <a:spcPts val="0"/>
-              </a:spcBef>
-              <a:spcAft>
-                <a:spcPts val="0"/>
-              </a:spcAft>
-              <a:buNone/>
-            </a:pPr>
-            <a:r>
-              <a:rPr lang="uk" sz="3200" dirty="0"/>
-              <a:t>Публікація результатів </a:t>
-            </a:r>
-            <a:endParaRPr sz="3200" dirty="0"/>
+            <a:r>
+              <a:rPr sz="3200"/>
+              <a:t>Апробація результатів</a:t>
+            </a:r>
           </a:p>
         </p:txBody>
       </p:sp>
@@ -8303,40 +8182,24 @@
           </a:bodyPr>
           <a:lstStyle/>
           <a:p>
-            <a:pPr marL="0" lvl="0" indent="0" algn="l" rtl="0">
-              <a:spcBef>
-                <a:spcPts val="0"/>
-              </a:spcBef>
-              <a:spcAft>
-                <a:spcPts val="0"/>
-              </a:spcAft>
-              <a:buNone/>
-            </a:pPr>
-            <a:r>
-              <a:rPr lang="uk" dirty="0"/>
-              <a:t>сертифікат про участь у конференціях</a:t>
-            </a:r>
-            <a:endParaRPr dirty="0">
-              <a:latin typeface="Economica" panose="020B0604020202020204" charset="0"/>
-            </a:endParaRPr>
-          </a:p>
-          <a:p>
-            <a:pPr marL="0" lvl="0" indent="0" algn="l" rtl="0">
-              <a:spcBef>
-                <a:spcPts val="1200"/>
-              </a:spcBef>
-              <a:spcAft>
-                <a:spcPts val="1200"/>
-              </a:spcAft>
-              <a:buNone/>
-            </a:pPr>
-            <a:r>
-              <a:rPr lang="uk" dirty="0"/>
-              <a:t>копія опублікованої статті</a:t>
-            </a:r>
-            <a:endParaRPr dirty="0">
-              <a:latin typeface="Economica" panose="020B0604020202020204" charset="0"/>
-            </a:endParaRPr>
+            <a:r>
+              <a:t>Результати дослідження апробовано на двох наукових конференціях:</a:t>
+            </a:r>
+          </a:p>
+          <a:p>
+            <a:r>
+              <a:t>1. 2-я Міжнародна науково-практична конференція «Innovative Research in Science and Economy» — стаття «Порівняльний аналіз ефективності моделей векторних ембеддінгів для задач семантичного пошуку в корпоративних базах знань»</a:t>
+            </a:r>
+          </a:p>
+          <a:p>
+            <a:r>
+              <a:t>2. 30-й Міжнародний молодіжний форум «Радіоелектроніка та молодь у XXI столітті» (ХНУРЕ) — тези «Підвищення якості семантичного пошуку в базах знань із використанням векторних подань»</a:t>
+            </a:r>
+          </a:p>
+          <a:p>
+            <a:r>
+              <a:t>Опубліковано 2 наукові праці у співавторстві з науковим керівником</a:t>
+            </a:r>
           </a:p>
         </p:txBody>
       </p:sp>
@@ -8454,20 +8317,10 @@
           </a:bodyPr>
           <a:lstStyle/>
           <a:p>
-            <a:pPr marL="0" lvl="0" indent="0" algn="l" rtl="0">
-              <a:spcBef>
-                <a:spcPts val="0"/>
-              </a:spcBef>
-              <a:spcAft>
-                <a:spcPts val="0"/>
-              </a:spcAft>
-              <a:buNone/>
-            </a:pPr>
-            <a:r>
-              <a:rPr lang="uk" sz="3200" dirty="0"/>
-              <a:t>Підсумки </a:t>
-            </a:r>
-            <a:endParaRPr sz="3200" dirty="0"/>
+            <a:r>
+              <a:rPr sz="3200"/>
+              <a:t>Підсумки та перспективи</a:t>
+            </a:r>
           </a:p>
         </p:txBody>
       </p:sp>
@@ -8496,40 +8349,49 @@
           </a:bodyPr>
           <a:lstStyle/>
           <a:p>
-            <a:pPr marL="0" lvl="0" indent="0" algn="l" rtl="0">
-              <a:spcBef>
-                <a:spcPts val="0"/>
-              </a:spcBef>
-              <a:spcAft>
-                <a:spcPts val="0"/>
-              </a:spcAft>
-              <a:buNone/>
-            </a:pPr>
-            <a:r>
-              <a:rPr lang="uk" dirty="0"/>
-              <a:t>реалістичність та корисність отриманих результатів </a:t>
-            </a:r>
-            <a:endParaRPr dirty="0">
-              <a:latin typeface="Economica" panose="020B0604020202020204" charset="0"/>
-            </a:endParaRPr>
-          </a:p>
-          <a:p>
-            <a:pPr marL="0" lvl="0" indent="0" algn="l" rtl="0">
-              <a:spcBef>
-                <a:spcPts val="1200"/>
-              </a:spcBef>
-              <a:spcAft>
-                <a:spcPts val="1200"/>
-              </a:spcAft>
-              <a:buNone/>
-            </a:pPr>
-            <a:r>
-              <a:rPr lang="uk" dirty="0"/>
-              <a:t>можливий розвиток досліджень </a:t>
-            </a:r>
-            <a:endParaRPr dirty="0">
-              <a:latin typeface="Economica" panose="020B0604020202020204" charset="0"/>
-            </a:endParaRPr>
+            <a:r>
+              <a:t>Поставлену мету досягнуто: визначено доцільність застосування сучасних моделей векторних ембеддінгів для семантичного пошуку у корпоративних базах знань</a:t>
+            </a:r>
+          </a:p>
+          <a:p>
+            <a:r>
+              <a:t>Розроблено програмну систему та власноруч сформовано benchmark dataset для україномовних доменно-специфічних колекцій</a:t>
+            </a:r>
+          </a:p>
+          <a:p>
+            <a:r>
+              <a:t>Практичні рекомендації для впровадження:</a:t>
+            </a:r>
+          </a:p>
+          <a:p>
+            <a:r>
+              <a:t>  – BGE-M3 як основна модель за якістю та стабільністю</a:t>
+            </a:r>
+          </a:p>
+          <a:p>
+            <a:r>
+              <a:t>  – E5-base як швидка альтернатива для інтерактивного пошуку</a:t>
+            </a:r>
+          </a:p>
+          <a:p>
+            <a:r>
+              <a:t>  – Qwen3-Embedding — лише за наявності GPU</a:t>
+            </a:r>
+          </a:p>
+          <a:p>
+            <a:r>
+              <a:t>  – BM25 залишається конкурентним базелайном у певних доменах</a:t>
+            </a:r>
+          </a:p>
+          <a:p>
+            <a:r>
+              <a:t>Перспективи: розширення benchmark-наборів, інтеграція reranking-підходів, повноцінна RAG-архітектура</a:t>
+            </a:r>
+          </a:p>
+          <a:p>
+            <a:r>
+              <a:t>Дякую за увагу!</a:t>
+            </a:r>
           </a:p>
         </p:txBody>
       </p:sp>
@@ -8647,20 +8509,10 @@
           </a:bodyPr>
           <a:lstStyle/>
           <a:p>
-            <a:pPr marL="0" lvl="0" indent="0" algn="l" rtl="0">
-              <a:spcBef>
-                <a:spcPts val="0"/>
-              </a:spcBef>
-              <a:spcAft>
-                <a:spcPts val="0"/>
-              </a:spcAft>
-              <a:buNone/>
-            </a:pPr>
-            <a:r>
-              <a:rPr lang="uk" sz="3200" dirty="0"/>
-              <a:t>Дослідження</a:t>
-            </a:r>
-            <a:endParaRPr sz="3200" dirty="0"/>
+            <a:r>
+              <a:rPr sz="3200"/>
+              <a:t>Актуальність та мета дослідження</a:t>
+            </a:r>
           </a:p>
         </p:txBody>
       </p:sp>
@@ -8689,72 +8541,29 @@
           </a:bodyPr>
           <a:lstStyle/>
           <a:p>
-            <a:pPr marL="0" lvl="0" indent="0" algn="l" rtl="0">
-              <a:spcBef>
-                <a:spcPts val="0"/>
-              </a:spcBef>
-              <a:spcAft>
-                <a:spcPts val="0"/>
-              </a:spcAft>
-              <a:buNone/>
-            </a:pPr>
-            <a:r>
-              <a:rPr lang="uk" dirty="0"/>
-              <a:t>Актуальність та стан розвитку галузі </a:t>
-            </a:r>
-            <a:endParaRPr dirty="0">
-              <a:latin typeface="Economica" panose="020B0604020202020204" charset="0"/>
-            </a:endParaRPr>
-          </a:p>
-          <a:p>
-            <a:pPr marL="0" lvl="0" indent="0" algn="l" rtl="0">
-              <a:spcBef>
-                <a:spcPts val="1200"/>
-              </a:spcBef>
-              <a:spcAft>
-                <a:spcPts val="0"/>
-              </a:spcAft>
-              <a:buNone/>
-            </a:pPr>
-            <a:r>
-              <a:rPr lang="uk" dirty="0"/>
-              <a:t>Чітке визначення напряму дослідження</a:t>
-            </a:r>
-            <a:endParaRPr dirty="0">
-              <a:latin typeface="Economica" panose="020B0604020202020204" charset="0"/>
-            </a:endParaRPr>
-          </a:p>
-          <a:p>
-            <a:pPr marL="0" lvl="0" indent="0" algn="l" rtl="0">
-              <a:spcBef>
-                <a:spcPts val="1200"/>
-              </a:spcBef>
-              <a:spcAft>
-                <a:spcPts val="0"/>
-              </a:spcAft>
-              <a:buNone/>
-            </a:pPr>
-            <a:r>
-              <a:rPr lang="uk" dirty="0"/>
-              <a:t>Об’єкт дослідження</a:t>
-            </a:r>
-            <a:endParaRPr dirty="0">
-              <a:latin typeface="Economica" panose="020B0604020202020204" charset="0"/>
-            </a:endParaRPr>
-          </a:p>
-          <a:p>
-            <a:pPr marL="0" lvl="0" indent="0" algn="l" rtl="0">
-              <a:spcBef>
-                <a:spcPts val="1200"/>
-              </a:spcBef>
-              <a:spcAft>
-                <a:spcPts val="1200"/>
-              </a:spcAft>
-              <a:buNone/>
-            </a:pPr>
-            <a:endParaRPr dirty="0">
-              <a:latin typeface="Economica" panose="020B0604020202020204" charset="0"/>
-            </a:endParaRPr>
+            <a:r>
+              <a:t>Актуальність: експоненційне зростання обсягів цифрової інформації у корпоративних базах знань; класичний keyword-пошук обмежений; розвиток LLM/RAG-систем робить retrieval-якість критичною</a:t>
+            </a:r>
+          </a:p>
+          <a:p>
+            <a:r>
+              <a:t>Об'єкт: процеси формування та використання векторних подань текстових даних у системах семантичного пошуку</a:t>
+            </a:r>
+          </a:p>
+          <a:p>
+            <a:r>
+              <a:t>Предмет: моделі векторних ембеддінгів для корпоративних баз знань</a:t>
+            </a:r>
+          </a:p>
+          <a:p>
+            <a:r>
+              <a:t>Мета: визначення доцільності застосування сучасних моделей векторних ембеддінгів для підвищення ефективності семантичного пошуку у корпоративних базах знань шляхом їх порівняльного експериментального дослідження</a:t>
+            </a:r>
+          </a:p>
+          <a:p>
+            <a:r>
+              <a:t>Задачі: огляд предметної галузі; аналіз сучасних embedding-моделей; формування benchmark dataset; реалізація системи; експериментальна оцінка; багатокритеріальний вибір оптимальної моделі</a:t>
+            </a:r>
           </a:p>
         </p:txBody>
       </p:sp>
@@ -8872,20 +8681,10 @@
           </a:bodyPr>
           <a:lstStyle/>
           <a:p>
-            <a:pPr marL="0" lvl="0" indent="0" algn="l" rtl="0">
-              <a:spcBef>
-                <a:spcPts val="0"/>
-              </a:spcBef>
-              <a:spcAft>
-                <a:spcPts val="0"/>
-              </a:spcAft>
-              <a:buNone/>
-            </a:pPr>
-            <a:r>
-              <a:rPr lang="uk" sz="3200" dirty="0"/>
-              <a:t>Огляд літератури (аналогів) </a:t>
-            </a:r>
-            <a:endParaRPr sz="3200" dirty="0"/>
+            <a:r>
+              <a:rPr sz="3200"/>
+              <a:t>Огляд літератури</a:t>
+            </a:r>
           </a:p>
         </p:txBody>
       </p:sp>
@@ -8914,78 +8713,39 @@
           </a:bodyPr>
           <a:lstStyle/>
           <a:p>
-            <a:pPr marL="0" lvl="0" indent="0" algn="l" rtl="0">
-              <a:spcBef>
-                <a:spcPts val="1500"/>
-              </a:spcBef>
-              <a:spcAft>
-                <a:spcPts val="0"/>
-              </a:spcAft>
-              <a:buNone/>
-            </a:pPr>
-            <a:r>
-              <a:rPr lang="uk" dirty="0">
-                <a:solidFill>
-                  <a:srgbClr val="0D0D0D"/>
-                </a:solidFill>
-                <a:highlight>
-                  <a:srgbClr val="FFFFFF"/>
-                </a:highlight>
-              </a:rPr>
-              <a:t>Перелік основних джерел та теорій у галузі</a:t>
-            </a:r>
-            <a:endParaRPr dirty="0">
-              <a:solidFill>
-                <a:srgbClr val="0D0D0D"/>
-              </a:solidFill>
-              <a:highlight>
-                <a:srgbClr val="FFFFFF"/>
-              </a:highlight>
-              <a:latin typeface="Economica" panose="020B0604020202020204" charset="0"/>
-            </a:endParaRPr>
-          </a:p>
-          <a:p>
-            <a:pPr marL="0" lvl="0" indent="0" algn="l" rtl="0">
-              <a:spcBef>
-                <a:spcPts val="1500"/>
-              </a:spcBef>
-              <a:spcAft>
-                <a:spcPts val="0"/>
-              </a:spcAft>
-              <a:buNone/>
-            </a:pPr>
-            <a:r>
-              <a:rPr lang="uk" dirty="0">
-                <a:solidFill>
-                  <a:srgbClr val="0D0D0D"/>
-                </a:solidFill>
-                <a:highlight>
-                  <a:srgbClr val="FFFFFF"/>
-                </a:highlight>
-              </a:rPr>
-              <a:t>Зазначення прогалин у наявних дослідженнях</a:t>
-            </a:r>
-            <a:endParaRPr dirty="0">
-              <a:solidFill>
-                <a:srgbClr val="0D0D0D"/>
-              </a:solidFill>
-              <a:highlight>
-                <a:srgbClr val="FFFFFF"/>
-              </a:highlight>
-              <a:latin typeface="Economica" panose="020B0604020202020204" charset="0"/>
-            </a:endParaRPr>
-          </a:p>
-          <a:p>
-            <a:pPr marL="0" lvl="0" indent="0" algn="l" rtl="0">
-              <a:spcBef>
-                <a:spcPts val="1500"/>
-              </a:spcBef>
-              <a:spcAft>
-                <a:spcPts val="1200"/>
-              </a:spcAft>
-              <a:buNone/>
-            </a:pPr>
-            <a:endParaRPr dirty="0"/>
+            <a:r>
+              <a:t>Фундаментальні роботи: Mikolov (Word2Vec), Pennington (GloVe), Devlin (BERT), Reimers (Sentence-BERT)</a:t>
+            </a:r>
+          </a:p>
+          <a:p>
+            <a:r>
+              <a:t>Сучасні embedding-моделі: Wang (E5), Chen (BGE-M3), Nussbaum (nomic-embed-text), Zhang (Qwen3-Embedding)</a:t>
+            </a:r>
+          </a:p>
+          <a:p>
+            <a:r>
+              <a:t>Лексичний базелайн: Robertson, Zaragoza (BM25)</a:t>
+            </a:r>
+          </a:p>
+          <a:p>
+            <a:r>
+              <a:t>Бенчмарки і метрики: Thakur (BEIR), Muennighoff (MTEB), Järvelin (nDCG)</a:t>
+            </a:r>
+          </a:p>
+          <a:p>
+            <a:r>
+              <a:t>RAG-парадигма: Lewis (Retrieval-Augmented Generation), Gao (RAG Survey)</a:t>
+            </a:r>
+          </a:p>
+          <a:p>
+            <a:r>
+              <a:t>Прогалина: відсутність порівняльних досліджень embedding-моделей на україномовних доменно-специфічних колекціях</a:t>
+            </a:r>
+          </a:p>
+          <a:p>
+            <a:r>
+              <a:t>Загалом використано 32 наукових джерела</a:t>
+            </a:r>
           </a:p>
         </p:txBody>
       </p:sp>
@@ -9103,20 +8863,10 @@
           </a:bodyPr>
           <a:lstStyle/>
           <a:p>
-            <a:pPr marL="0" lvl="0" indent="0" algn="l" rtl="0">
-              <a:spcBef>
-                <a:spcPts val="0"/>
-              </a:spcBef>
-              <a:spcAft>
-                <a:spcPts val="0"/>
-              </a:spcAft>
-              <a:buNone/>
-            </a:pPr>
-            <a:r>
-              <a:rPr lang="uk" sz="3200" dirty="0"/>
+            <a:r>
+              <a:rPr sz="3200"/>
               <a:t>Постановка задачі</a:t>
             </a:r>
-            <a:endParaRPr sz="3200" dirty="0"/>
           </a:p>
         </p:txBody>
       </p:sp>
@@ -9145,80 +8895,39 @@
           </a:bodyPr>
           <a:lstStyle/>
           <a:p>
-            <a:pPr marL="0" lvl="0" indent="0" algn="l" rtl="0">
-              <a:spcBef>
-                <a:spcPts val="1500"/>
-              </a:spcBef>
-              <a:spcAft>
-                <a:spcPts val="0"/>
-              </a:spcAft>
-              <a:buNone/>
-            </a:pPr>
-            <a:r>
-              <a:rPr lang="uk" dirty="0">
-                <a:solidFill>
-                  <a:srgbClr val="0D0D0D"/>
-                </a:solidFill>
-                <a:highlight>
-                  <a:srgbClr val="FFFFFF"/>
-                </a:highlight>
-              </a:rPr>
-              <a:t>Чітке формулювання проблеми</a:t>
-            </a:r>
-            <a:endParaRPr dirty="0">
-              <a:solidFill>
-                <a:srgbClr val="0D0D0D"/>
-              </a:solidFill>
-              <a:highlight>
-                <a:srgbClr val="FFFFFF"/>
-              </a:highlight>
-              <a:latin typeface="Economica" panose="020B0604020202020204" charset="0"/>
-            </a:endParaRPr>
-          </a:p>
-          <a:p>
-            <a:pPr marL="0" lvl="0" indent="0" algn="l" rtl="0">
-              <a:spcBef>
-                <a:spcPts val="1500"/>
-              </a:spcBef>
-              <a:spcAft>
-                <a:spcPts val="0"/>
-              </a:spcAft>
-              <a:buNone/>
-            </a:pPr>
-            <a:r>
-              <a:rPr lang="uk" dirty="0">
-                <a:solidFill>
-                  <a:srgbClr val="0D0D0D"/>
-                </a:solidFill>
-                <a:highlight>
-                  <a:srgbClr val="FFFFFF"/>
-                </a:highlight>
-              </a:rPr>
-              <a:t>Опис очікуваних результатів</a:t>
-            </a:r>
-            <a:endParaRPr dirty="0">
-              <a:solidFill>
-                <a:srgbClr val="0D0D0D"/>
-              </a:solidFill>
-              <a:highlight>
-                <a:srgbClr val="FFFFFF"/>
-              </a:highlight>
-              <a:latin typeface="Economica" panose="020B0604020202020204" charset="0"/>
-            </a:endParaRPr>
-          </a:p>
-          <a:p>
-            <a:pPr marL="0" lvl="0" indent="0" algn="l" rtl="0">
-              <a:spcBef>
-                <a:spcPts val="1500"/>
-              </a:spcBef>
-              <a:spcAft>
-                <a:spcPts val="1200"/>
-              </a:spcAft>
-              <a:buNone/>
-            </a:pPr>
-            <a:endParaRPr dirty="0">
-              <a:latin typeface="Economica" panose="020B0604020202020204" charset="0"/>
-            </a:endParaRPr>
+            <a:r>
+              <a:t>Проблема: у реальних корпоративних системах недостатньо просто застосувати сучасну embedding-модель — необхідно обґрунтовано визначити оптимальну за балансом якості, швидкодії та ресурсів</a:t>
+            </a:r>
+          </a:p>
+          <a:p>
+            <a:r>
+              <a:t>Очікувані результати:</a:t>
+            </a:r>
+          </a:p>
+          <a:p>
+            <a:r>
+              <a:t>  – реалізована система семантичного пошуку з підтримкою документів PDF/DOCX/TXT/MD</a:t>
+            </a:r>
+          </a:p>
+          <a:p>
+            <a:r>
+              <a:t>  – власноруч сформований domain-specific україномовний benchmark dataset</a:t>
+            </a:r>
+          </a:p>
+          <a:p>
+            <a:r>
+              <a:t>  – кількісне порівняння 4 embedding-моделей + BM25 baseline на 3 доменах</a:t>
+            </a:r>
+          </a:p>
+          <a:p>
+            <a:r>
+              <a:t>  – багатокритеріальний вибір оптимальної моделі (Парето + лінійна згортка)</a:t>
+            </a:r>
+          </a:p>
+          <a:p>
+            <a:r>
+              <a:t>  – обґрунтовані практичні рекомендації для впровадження</a:t>
+            </a:r>
           </a:p>
         </p:txBody>
       </p:sp>
@@ -9336,20 +9045,10 @@
           </a:bodyPr>
           <a:lstStyle/>
           <a:p>
-            <a:pPr marL="0" lvl="0" indent="0" algn="l" rtl="0">
-              <a:spcBef>
-                <a:spcPts val="0"/>
-              </a:spcBef>
-              <a:spcAft>
-                <a:spcPts val="0"/>
-              </a:spcAft>
-              <a:buNone/>
-            </a:pPr>
-            <a:r>
-              <a:rPr lang="uk" sz="3200" dirty="0"/>
-              <a:t>Методологія </a:t>
-            </a:r>
-            <a:endParaRPr sz="3200" dirty="0"/>
+            <a:r>
+              <a:rPr sz="3200"/>
+              <a:t>Методологія дослідження</a:t>
+            </a:r>
           </a:p>
         </p:txBody>
       </p:sp>
@@ -9378,80 +9077,34 @@
           </a:bodyPr>
           <a:lstStyle/>
           <a:p>
-            <a:pPr marL="0" lvl="0" indent="0" algn="l" rtl="0">
-              <a:spcBef>
-                <a:spcPts val="1500"/>
-              </a:spcBef>
-              <a:spcAft>
-                <a:spcPts val="0"/>
-              </a:spcAft>
-              <a:buNone/>
-            </a:pPr>
-            <a:r>
-              <a:rPr lang="uk" dirty="0">
-                <a:solidFill>
-                  <a:srgbClr val="0D0D0D"/>
-                </a:solidFill>
-                <a:highlight>
-                  <a:srgbClr val="FFFFFF"/>
-                </a:highlight>
-              </a:rPr>
-              <a:t>Опис використаних методів дослідження</a:t>
-            </a:r>
-            <a:endParaRPr dirty="0">
-              <a:solidFill>
-                <a:srgbClr val="0D0D0D"/>
-              </a:solidFill>
-              <a:highlight>
-                <a:srgbClr val="FFFFFF"/>
-              </a:highlight>
-              <a:latin typeface="Economica" panose="020B0604020202020204" charset="0"/>
-            </a:endParaRPr>
-          </a:p>
-          <a:p>
-            <a:pPr marL="0" lvl="0" indent="0" algn="l" rtl="0">
-              <a:spcBef>
-                <a:spcPts val="1500"/>
-              </a:spcBef>
-              <a:spcAft>
-                <a:spcPts val="0"/>
-              </a:spcAft>
-              <a:buNone/>
-            </a:pPr>
-            <a:r>
-              <a:rPr lang="uk" dirty="0">
-                <a:solidFill>
-                  <a:srgbClr val="0D0D0D"/>
-                </a:solidFill>
-                <a:highlight>
-                  <a:srgbClr val="FFFFFF"/>
-                </a:highlight>
-              </a:rPr>
-              <a:t>Інструментарій та технології, використані в роботі</a:t>
-            </a:r>
-            <a:endParaRPr dirty="0">
-              <a:solidFill>
-                <a:srgbClr val="0D0D0D"/>
-              </a:solidFill>
-              <a:highlight>
-                <a:srgbClr val="FFFFFF"/>
-              </a:highlight>
-              <a:latin typeface="Economica" panose="020B0604020202020204" charset="0"/>
-            </a:endParaRPr>
-          </a:p>
-          <a:p>
-            <a:pPr marL="0" lvl="0" indent="0" algn="l" rtl="0">
-              <a:spcBef>
-                <a:spcPts val="1500"/>
-              </a:spcBef>
-              <a:spcAft>
-                <a:spcPts val="1200"/>
-              </a:spcAft>
-              <a:buNone/>
-            </a:pPr>
-            <a:endParaRPr dirty="0">
-              <a:latin typeface="Economica" panose="020B0604020202020204" charset="0"/>
-            </a:endParaRPr>
+            <a:r>
+              <a:t>Метрики оцінювання retrieval-якості: nDCG@10, MRR@10, Recall@10, P@10</a:t>
+            </a:r>
+          </a:p>
+          <a:p>
+            <a:r>
+              <a:t>Метрика швидкодії: середній час відповіді на запит (мс/запит)</a:t>
+            </a:r>
+          </a:p>
+          <a:p>
+            <a:r>
+              <a:t>Статистичний аналіз: bootstrap-оцінка 95% довірчого інтервалу для nDCG@10 (n = 2000)</a:t>
+            </a:r>
+          </a:p>
+          <a:p>
+            <a:r>
+              <a:t>Багатокритеріальний вибір: принцип Парето-домінування + лінійна адитивна згортка з нормалізацією критеріїв</a:t>
+            </a:r>
+          </a:p>
+          <a:p>
+            <a:r>
+              <a:t>Метод призначення ваг: ранжування критеріїв за важливістю з доменно-специфічними профілями</a:t>
+            </a:r>
+          </a:p>
+          <a:p>
+            <a:r>
+              <a:t>Інструментарій: Python 3.11, sentence-transformers, FAISS, rank_bm25, Flask, NumPy, scikit-learn</a:t>
+            </a:r>
           </a:p>
         </p:txBody>
       </p:sp>
@@ -9569,20 +9222,10 @@
           </a:bodyPr>
           <a:lstStyle/>
           <a:p>
-            <a:pPr marL="0" lvl="0" indent="0" algn="l" rtl="0">
-              <a:spcBef>
-                <a:spcPts val="0"/>
-              </a:spcBef>
-              <a:spcAft>
-                <a:spcPts val="0"/>
-              </a:spcAft>
-              <a:buNone/>
-            </a:pPr>
-            <a:r>
-              <a:rPr lang="uk" sz="3200" dirty="0"/>
-              <a:t>Архітектура система для проведення експериментального дослідження</a:t>
-            </a:r>
-            <a:endParaRPr sz="3200" dirty="0"/>
+            <a:r>
+              <a:rPr sz="3200"/>
+              <a:t>Архітектура системи</a:t>
+            </a:r>
           </a:p>
         </p:txBody>
       </p:sp>
@@ -9611,80 +9254,44 @@
           </a:bodyPr>
           <a:lstStyle/>
           <a:p>
-            <a:pPr marL="0" lvl="0" indent="0" algn="l" rtl="0">
-              <a:spcBef>
-                <a:spcPts val="1500"/>
-              </a:spcBef>
-              <a:spcAft>
-                <a:spcPts val="0"/>
-              </a:spcAft>
-              <a:buNone/>
-            </a:pPr>
-            <a:r>
-              <a:rPr lang="uk" dirty="0">
-                <a:solidFill>
-                  <a:srgbClr val="0D0D0D"/>
-                </a:solidFill>
-                <a:highlight>
-                  <a:srgbClr val="FFFFFF"/>
-                </a:highlight>
-              </a:rPr>
-              <a:t>Схема архітектури розробленої системи</a:t>
-            </a:r>
-            <a:endParaRPr dirty="0">
-              <a:solidFill>
-                <a:srgbClr val="0D0D0D"/>
-              </a:solidFill>
-              <a:highlight>
-                <a:srgbClr val="FFFFFF"/>
-              </a:highlight>
-              <a:latin typeface="Economica" panose="020B0604020202020204" charset="0"/>
-            </a:endParaRPr>
-          </a:p>
-          <a:p>
-            <a:pPr marL="0" lvl="0" indent="0" algn="l" rtl="0">
-              <a:spcBef>
-                <a:spcPts val="1500"/>
-              </a:spcBef>
-              <a:spcAft>
-                <a:spcPts val="0"/>
-              </a:spcAft>
-              <a:buNone/>
-            </a:pPr>
-            <a:r>
-              <a:rPr lang="uk" dirty="0">
-                <a:solidFill>
-                  <a:srgbClr val="0D0D0D"/>
-                </a:solidFill>
-                <a:highlight>
-                  <a:srgbClr val="FFFFFF"/>
-                </a:highlight>
-              </a:rPr>
-              <a:t>Опис ключових компонентів</a:t>
-            </a:r>
-            <a:endParaRPr dirty="0">
-              <a:solidFill>
-                <a:srgbClr val="0D0D0D"/>
-              </a:solidFill>
-              <a:highlight>
-                <a:srgbClr val="FFFFFF"/>
-              </a:highlight>
-              <a:latin typeface="Economica" panose="020B0604020202020204" charset="0"/>
-            </a:endParaRPr>
-          </a:p>
-          <a:p>
-            <a:pPr marL="0" lvl="0" indent="0" algn="l" rtl="0">
-              <a:spcBef>
-                <a:spcPts val="1500"/>
-              </a:spcBef>
-              <a:spcAft>
-                <a:spcPts val="1200"/>
-              </a:spcAft>
-              <a:buNone/>
-            </a:pPr>
-            <a:endParaRPr dirty="0">
-              <a:latin typeface="Economica" panose="020B0604020202020204" charset="0"/>
-            </a:endParaRPr>
+            <a:r>
+              <a:t>Pipeline експерименту: документи → попередня обробка → чанкінг → ембеддінг → FAISS-індекс → запит → top-k результати → метрики</a:t>
+            </a:r>
+          </a:p>
+          <a:p>
+            <a:r>
+              <a:t>Основні компоненти:</a:t>
+            </a:r>
+          </a:p>
+          <a:p>
+            <a:r>
+              <a:t>  – build_index.py — побудова індексу для (модель, домен)</a:t>
+            </a:r>
+          </a:p>
+          <a:p>
+            <a:r>
+              <a:t>  – evaluate_benchmark.py — обчислення метрик retrieval-якості</a:t>
+            </a:r>
+          </a:p>
+          <a:p>
+            <a:r>
+              <a:t>  – embedding_models.py — уніфікований інтерфейс для 5 моделей</a:t>
+            </a:r>
+          </a:p>
+          <a:p>
+            <a:r>
+              <a:t>  – run_all_benchmarks.py — масовий прогін усіх (модель, домен)</a:t>
+            </a:r>
+          </a:p>
+          <a:p>
+            <a:r>
+              <a:t>Web-інтерфейс: Flask-додаток з вибором моделі, домену та інтерактивним пошуком</a:t>
+            </a:r>
+          </a:p>
+          <a:p>
+            <a:r>
+              <a:t>Зберігання артефактів: faiss.index + meta.jsonl + model.json для кожної (модель, домен)</a:t>
+            </a:r>
           </a:p>
         </p:txBody>
       </p:sp>
@@ -9802,20 +9409,10 @@
           </a:bodyPr>
           <a:lstStyle/>
           <a:p>
-            <a:pPr marL="0" lvl="0" indent="0" algn="l" rtl="0">
-              <a:spcBef>
-                <a:spcPts val="0"/>
-              </a:spcBef>
-              <a:spcAft>
-                <a:spcPts val="0"/>
-              </a:spcAft>
-              <a:buNone/>
-            </a:pPr>
-            <a:r>
-              <a:rPr lang="uk" sz="3200" dirty="0"/>
-              <a:t>Опис програмного забезпечення, що було використано у дослідженні</a:t>
-            </a:r>
-            <a:endParaRPr sz="3200" dirty="0"/>
+            <a:r>
+              <a:rPr sz="3200"/>
+              <a:t>Програмне забезпечення</a:t>
+            </a:r>
           </a:p>
         </p:txBody>
       </p:sp>
@@ -9844,80 +9441,39 @@
           </a:bodyPr>
           <a:lstStyle/>
           <a:p>
-            <a:pPr marL="0" lvl="0" indent="0" algn="l" rtl="0">
-              <a:spcBef>
-                <a:spcPts val="1500"/>
-              </a:spcBef>
-              <a:spcAft>
-                <a:spcPts val="0"/>
-              </a:spcAft>
-              <a:buNone/>
-            </a:pPr>
-            <a:r>
-              <a:rPr lang="uk">
-                <a:solidFill>
-                  <a:srgbClr val="0D0D0D"/>
-                </a:solidFill>
-                <a:highlight>
-                  <a:srgbClr val="FFFFFF"/>
-                </a:highlight>
-              </a:rPr>
-              <a:t>Опис процесу розробки</a:t>
-            </a:r>
-            <a:endParaRPr>
-              <a:solidFill>
-                <a:srgbClr val="0D0D0D"/>
-              </a:solidFill>
-              <a:highlight>
-                <a:srgbClr val="FFFFFF"/>
-              </a:highlight>
-              <a:latin typeface="Economica" panose="020B0604020202020204" charset="0"/>
-            </a:endParaRPr>
-          </a:p>
-          <a:p>
-            <a:pPr marL="0" lvl="0" indent="0" algn="l" rtl="0">
-              <a:spcBef>
-                <a:spcPts val="1500"/>
-              </a:spcBef>
-              <a:spcAft>
-                <a:spcPts val="0"/>
-              </a:spcAft>
-              <a:buNone/>
-            </a:pPr>
-            <a:r>
-              <a:rPr lang="uk">
-                <a:solidFill>
-                  <a:srgbClr val="0D0D0D"/>
-                </a:solidFill>
-                <a:highlight>
-                  <a:srgbClr val="FFFFFF"/>
-                </a:highlight>
-              </a:rPr>
-              <a:t>Вибрані мови програмування та фреймворки</a:t>
-            </a:r>
-            <a:endParaRPr>
-              <a:solidFill>
-                <a:srgbClr val="0D0D0D"/>
-              </a:solidFill>
-              <a:highlight>
-                <a:srgbClr val="FFFFFF"/>
-              </a:highlight>
-              <a:latin typeface="Economica" panose="020B0604020202020204" charset="0"/>
-            </a:endParaRPr>
-          </a:p>
-          <a:p>
-            <a:pPr marL="0" lvl="0" indent="0" algn="l" rtl="0">
-              <a:spcBef>
-                <a:spcPts val="1500"/>
-              </a:spcBef>
-              <a:spcAft>
-                <a:spcPts val="1200"/>
-              </a:spcAft>
-              <a:buNone/>
-            </a:pPr>
-            <a:endParaRPr>
-              <a:latin typeface="Economica" panose="020B0604020202020204" charset="0"/>
-            </a:endParaRPr>
+            <a:r>
+              <a:t>Мова та середовище: Python 3.11, віртуальне середовище venv</a:t>
+            </a:r>
+          </a:p>
+          <a:p>
+            <a:r>
+              <a:t>Embedding-фреймворки: sentence-transformers (Hugging Face), trust_remote_code для nomic та Qwen3</a:t>
+            </a:r>
+          </a:p>
+          <a:p>
+            <a:r>
+              <a:t>Векторний індекс: FAISS IndexFlatIP з L2-нормалізацією векторів</a:t>
+            </a:r>
+          </a:p>
+          <a:p>
+            <a:r>
+              <a:t>Лексичний базелайн: rank_bm25 (Okapi BM25)</a:t>
+            </a:r>
+          </a:p>
+          <a:p>
+            <a:r>
+              <a:t>Web-фреймворк: Flask (Python)</a:t>
+            </a:r>
+          </a:p>
+          <a:p>
+            <a:r>
+              <a:t>Підтримувані формати документів: PDF, DOCX, TXT, MD</a:t>
+            </a:r>
+          </a:p>
+          <a:p>
+            <a:r>
+              <a:t>Моделі: BGE-M3 (BAAI), E5-base (intfloat/multilingual-e5-base), nomic-embed-text-v1.5, Qwen3-Embedding-0.6B (Alibaba)</a:t>
+            </a:r>
           </a:p>
         </p:txBody>
       </p:sp>
@@ -10035,20 +9591,10 @@
           </a:bodyPr>
           <a:lstStyle/>
           <a:p>
-            <a:pPr marL="0" lvl="0" indent="0" algn="l" rtl="0">
-              <a:spcBef>
-                <a:spcPts val="0"/>
-              </a:spcBef>
-              <a:spcAft>
-                <a:spcPts val="0"/>
-              </a:spcAft>
-              <a:buNone/>
-            </a:pPr>
-            <a:r>
-              <a:rPr lang="uk" sz="3200" dirty="0"/>
-              <a:t>Зміст проведеного експерименту</a:t>
-            </a:r>
-            <a:endParaRPr sz="3200" dirty="0"/>
+            <a:r>
+              <a:rPr sz="3200"/>
+              <a:t>Benchmark dataset та умови експерименту</a:t>
+            </a:r>
           </a:p>
         </p:txBody>
       </p:sp>
@@ -10077,94 +9623,39 @@
           </a:bodyPr>
           <a:lstStyle/>
           <a:p>
-            <a:pPr marL="0" lvl="0" indent="0" algn="l" rtl="0">
-              <a:spcBef>
-                <a:spcPts val="0"/>
-              </a:spcBef>
-              <a:spcAft>
-                <a:spcPts val="0"/>
-              </a:spcAft>
-              <a:buNone/>
-            </a:pPr>
-            <a:r>
-              <a:rPr lang="uk" dirty="0"/>
-              <a:t>Методи</a:t>
-            </a:r>
-            <a:endParaRPr dirty="0">
-              <a:latin typeface="Economica" panose="020B0604020202020204" charset="0"/>
-            </a:endParaRPr>
-          </a:p>
-          <a:p>
-            <a:pPr marL="0" lvl="0" indent="0" algn="l" rtl="0">
-              <a:spcBef>
-                <a:spcPts val="1200"/>
-              </a:spcBef>
-              <a:spcAft>
-                <a:spcPts val="0"/>
-              </a:spcAft>
-              <a:buNone/>
-            </a:pPr>
-            <a:r>
-              <a:rPr lang="uk" dirty="0"/>
-              <a:t>Вхідні дані</a:t>
-            </a:r>
-            <a:endParaRPr dirty="0">
-              <a:latin typeface="Economica" panose="020B0604020202020204" charset="0"/>
-            </a:endParaRPr>
-          </a:p>
-          <a:p>
-            <a:pPr marL="0" lvl="0" indent="0" algn="l" rtl="0">
-              <a:spcBef>
-                <a:spcPts val="1200"/>
-              </a:spcBef>
-              <a:spcAft>
-                <a:spcPts val="0"/>
-              </a:spcAft>
-              <a:buNone/>
-            </a:pPr>
-            <a:r>
-              <a:rPr lang="uk" dirty="0"/>
-              <a:t>Критерії </a:t>
-            </a:r>
-            <a:endParaRPr dirty="0">
-              <a:latin typeface="Economica" panose="020B0604020202020204" charset="0"/>
-            </a:endParaRPr>
-          </a:p>
-          <a:p>
-            <a:pPr marL="0" lvl="0" indent="0" algn="l" rtl="0">
-              <a:spcBef>
-                <a:spcPts val="1200"/>
-              </a:spcBef>
-              <a:spcAft>
-                <a:spcPts val="0"/>
-              </a:spcAft>
-              <a:buNone/>
-            </a:pPr>
-            <a:r>
-              <a:rPr lang="uk" dirty="0"/>
-              <a:t>Послідовність </a:t>
-            </a:r>
-            <a:endParaRPr dirty="0">
-              <a:latin typeface="Economica" panose="020B0604020202020204" charset="0"/>
-            </a:endParaRPr>
-          </a:p>
-          <a:p>
-            <a:pPr marL="0" lvl="0" indent="0" algn="l" rtl="0">
-              <a:spcBef>
-                <a:spcPts val="1200"/>
-              </a:spcBef>
-              <a:spcAft>
-                <a:spcPts val="1200"/>
-              </a:spcAft>
-              <a:buNone/>
-            </a:pPr>
-            <a:r>
-              <a:rPr lang="uk" dirty="0"/>
-              <a:t>Вимірювання</a:t>
-            </a:r>
-            <a:endParaRPr dirty="0">
-              <a:latin typeface="Economica" panose="020B0604020202020204" charset="0"/>
-            </a:endParaRPr>
+            <a:r>
+              <a:t>Власноруч сформований domain-specific україномовний benchmark dataset</a:t>
+            </a:r>
+          </a:p>
+          <a:p>
+            <a:r>
+              <a:t>Технічний домен: 10 документів, 178 чанків (програмна інженерія, ML, RAG, аномалії, 3D-друк)</a:t>
+            </a:r>
+          </a:p>
+          <a:p>
+            <a:r>
+              <a:t>Юридичний домен: 13 документів, 1046 чанків (кодекси, нормативно-правові акти)</a:t>
+            </a:r>
+          </a:p>
+          <a:p>
+            <a:r>
+              <a:t>Медичний домен: 9 документів, 267 чанків (клінічні протоколи, медичні рекомендації)</a:t>
+            </a:r>
+          </a:p>
+          <a:p>
+            <a:r>
+              <a:t>Усього: 32 документи, 1 491 чанк, 300 пошукових запитів (по 100 на домен)</a:t>
+            </a:r>
+          </a:p>
+          <a:p>
+            <a:r>
+              <a:t>Релевантні відповідності (qrels): сформовані автором вручну на рівні чанків</a:t>
+            </a:r>
+          </a:p>
+          <a:p>
+            <a:r>
+              <a:t>Учасники експерименту: 4 нейронні embedding-моделі + BM25 базелайн на кожному з 3 доменів (15 експериментів)</a:t>
+            </a:r>
           </a:p>
         </p:txBody>
       </p:sp>
@@ -10282,20 +9773,10 @@
           </a:bodyPr>
           <a:lstStyle/>
           <a:p>
-            <a:pPr marL="0" lvl="0" indent="0" algn="l" rtl="0">
-              <a:spcBef>
-                <a:spcPts val="0"/>
-              </a:spcBef>
-              <a:spcAft>
-                <a:spcPts val="0"/>
-              </a:spcAft>
-              <a:buNone/>
-            </a:pPr>
-            <a:r>
-              <a:rPr lang="uk" sz="3200" dirty="0"/>
-              <a:t>Результати експерименту </a:t>
-            </a:r>
-            <a:endParaRPr sz="3200" dirty="0"/>
+            <a:r>
+              <a:rPr sz="3200"/>
+              <a:t>Результати експерименту: nDCG@10</a:t>
+            </a:r>
           </a:p>
         </p:txBody>
       </p:sp>
@@ -10324,76 +9805,39 @@
           </a:bodyPr>
           <a:lstStyle/>
           <a:p>
-            <a:pPr marL="0" lvl="0" indent="0" algn="l" rtl="0">
-              <a:spcBef>
-                <a:spcPts val="0"/>
-              </a:spcBef>
-              <a:spcAft>
-                <a:spcPts val="0"/>
-              </a:spcAft>
-              <a:buNone/>
-            </a:pPr>
-            <a:r>
-              <a:rPr lang="uk" dirty="0"/>
-              <a:t>якісні та кількісні дані</a:t>
-            </a:r>
-            <a:endParaRPr dirty="0">
-              <a:latin typeface="Economica" panose="020B0604020202020204" charset="0"/>
-            </a:endParaRPr>
-          </a:p>
-          <a:p>
-            <a:pPr marL="0" lvl="0" indent="0" algn="l" rtl="0">
-              <a:spcBef>
-                <a:spcPts val="1200"/>
-              </a:spcBef>
-              <a:spcAft>
-                <a:spcPts val="0"/>
-              </a:spcAft>
-              <a:buNone/>
-            </a:pPr>
-            <a:r>
-              <a:rPr lang="uk" dirty="0"/>
-              <a:t>таблиці</a:t>
-            </a:r>
-            <a:endParaRPr dirty="0">
-              <a:latin typeface="Economica" panose="020B0604020202020204" charset="0"/>
-            </a:endParaRPr>
-          </a:p>
-          <a:p>
-            <a:pPr marL="0" lvl="0" indent="0" algn="l" rtl="0">
-              <a:spcBef>
-                <a:spcPts val="1200"/>
-              </a:spcBef>
-              <a:spcAft>
-                <a:spcPts val="0"/>
-              </a:spcAft>
-              <a:buNone/>
-            </a:pPr>
-            <a:r>
-              <a:rPr lang="uk" dirty="0"/>
-              <a:t>графіки</a:t>
-            </a:r>
-            <a:endParaRPr dirty="0">
-              <a:latin typeface="Economica" panose="020B0604020202020204" charset="0"/>
-            </a:endParaRPr>
-          </a:p>
-          <a:p>
-            <a:pPr marL="0" lvl="0" indent="0" algn="l" rtl="0">
-              <a:spcBef>
-                <a:spcPts val="1200"/>
-              </a:spcBef>
-              <a:spcAft>
-                <a:spcPts val="1200"/>
-              </a:spcAft>
-              <a:buNone/>
-            </a:pPr>
-            <a:r>
-              <a:rPr lang="uk" dirty="0"/>
-              <a:t>діаграми</a:t>
-            </a:r>
-            <a:endParaRPr dirty="0">
-              <a:latin typeface="Economica" panose="020B0604020202020204" charset="0"/>
-            </a:endParaRPr>
+            <a:r>
+              <a:t>Зведена таблиця nDCG@10 (вище — краще):</a:t>
+            </a:r>
+          </a:p>
+          <a:p>
+            <a:r>
+              <a:t>BGE-M3: технічний 0.6722  |  юридичний 0.3065  |  медичний 0.4339</a:t>
+            </a:r>
+          </a:p>
+          <a:p>
+            <a:r>
+              <a:t>Qwen3-Embedding-0.6B: 0.6325  |  0.3199  |  0.3629</a:t>
+            </a:r>
+          </a:p>
+          <a:p>
+            <a:r>
+              <a:t>E5-base: 0.6121  |  0.2567  |  0.3909</a:t>
+            </a:r>
+          </a:p>
+          <a:p>
+            <a:r>
+              <a:t>BM25 (базелайн): 0.4861  |  0.1875  |  0.3222</a:t>
+            </a:r>
+          </a:p>
+          <a:p>
+            <a:r>
+              <a:t>nomic-embed-text-v1.5: 0.3765  |  0.0951  |  0.1668</a:t>
+            </a:r>
+          </a:p>
+          <a:p>
+            <a:r>
+              <a:t>Bootstrap 95% CI (n = 2000) для технічного домену: BGE-M3 [0.606, 0.737] vs BM25 [0.431, 0.541] — інтервали не перетинаються (статистично значуща перевага)</a:t>
+            </a:r>
           </a:p>
         </p:txBody>
       </p:sp>

</xml_diff>